<commit_message>
Update Madera Transit Analysis.pptx
</commit_message>
<xml_diff>
--- a/Slide Deck/Madera Transit Analysis.pptx
+++ b/Slide Deck/Madera Transit Analysis.pptx
@@ -117,6 +117,11 @@
       </a:defRPr>
     </a:lvl9pPr>
   </p:defaultTextStyle>
+  <p:extLst>
+    <p:ext uri="{EFAFB233-063F-42B5-8137-9DF3F51BA10A}">
+      <p15:sldGuideLst xmlns:p15="http://schemas.microsoft.com/office/powerpoint/2012/main"/>
+    </p:ext>
+  </p:extLst>
 </p:presentation>
 </file>
 
@@ -362,7 +367,7 @@
           <a:p>
             <a:fld id="{766B0C42-5065-4BF6-B693-914B09332802}" type="datetimeFigureOut">
               <a:rPr lang="en-US" smtClean="0"/>
-              <a:t>6/6/2026</a:t>
+              <a:t>6/7/2026</a:t>
             </a:fld>
             <a:endParaRPr lang="en-US"/>
           </a:p>
@@ -570,7 +575,7 @@
           <a:p>
             <a:fld id="{766B0C42-5065-4BF6-B693-914B09332802}" type="datetimeFigureOut">
               <a:rPr lang="en-US" smtClean="0"/>
-              <a:t>6/6/2026</a:t>
+              <a:t>6/7/2026</a:t>
             </a:fld>
             <a:endParaRPr lang="en-US"/>
           </a:p>
@@ -842,7 +847,7 @@
           <a:p>
             <a:fld id="{766B0C42-5065-4BF6-B693-914B09332802}" type="datetimeFigureOut">
               <a:rPr lang="en-US" smtClean="0"/>
-              <a:t>6/6/2026</a:t>
+              <a:t>6/7/2026</a:t>
             </a:fld>
             <a:endParaRPr lang="en-US"/>
           </a:p>
@@ -1012,7 +1017,7 @@
           <a:p>
             <a:fld id="{766B0C42-5065-4BF6-B693-914B09332802}" type="datetimeFigureOut">
               <a:rPr lang="en-US" smtClean="0"/>
-              <a:t>6/6/2026</a:t>
+              <a:t>6/7/2026</a:t>
             </a:fld>
             <a:endParaRPr lang="en-US"/>
           </a:p>
@@ -1363,7 +1368,7 @@
           <a:p>
             <a:fld id="{766B0C42-5065-4BF6-B693-914B09332802}" type="datetimeFigureOut">
               <a:rPr lang="en-US" smtClean="0"/>
-              <a:t>6/6/2026</a:t>
+              <a:t>6/7/2026</a:t>
             </a:fld>
             <a:endParaRPr lang="en-US"/>
           </a:p>
@@ -1638,7 +1643,7 @@
           <a:p>
             <a:fld id="{766B0C42-5065-4BF6-B693-914B09332802}" type="datetimeFigureOut">
               <a:rPr lang="en-US" smtClean="0"/>
-              <a:t>6/6/2026</a:t>
+              <a:t>6/7/2026</a:t>
             </a:fld>
             <a:endParaRPr lang="en-US"/>
           </a:p>
@@ -2017,7 +2022,7 @@
           <a:p>
             <a:fld id="{766B0C42-5065-4BF6-B693-914B09332802}" type="datetimeFigureOut">
               <a:rPr lang="en-US" smtClean="0"/>
-              <a:t>6/6/2026</a:t>
+              <a:t>6/7/2026</a:t>
             </a:fld>
             <a:endParaRPr lang="en-US"/>
           </a:p>
@@ -2135,7 +2140,7 @@
           <a:p>
             <a:fld id="{766B0C42-5065-4BF6-B693-914B09332802}" type="datetimeFigureOut">
               <a:rPr lang="en-US" smtClean="0"/>
-              <a:t>6/6/2026</a:t>
+              <a:t>6/7/2026</a:t>
             </a:fld>
             <a:endParaRPr lang="en-US"/>
           </a:p>
@@ -2322,7 +2327,7 @@
           <a:p>
             <a:fld id="{766B0C42-5065-4BF6-B693-914B09332802}" type="datetimeFigureOut">
               <a:rPr lang="en-US" smtClean="0"/>
-              <a:t>6/6/2026</a:t>
+              <a:t>6/7/2026</a:t>
             </a:fld>
             <a:endParaRPr lang="en-US"/>
           </a:p>
@@ -2692,7 +2697,7 @@
           <a:p>
             <a:fld id="{766B0C42-5065-4BF6-B693-914B09332802}" type="datetimeFigureOut">
               <a:rPr lang="en-US" smtClean="0"/>
-              <a:t>6/6/2026</a:t>
+              <a:t>6/7/2026</a:t>
             </a:fld>
             <a:endParaRPr lang="en-US"/>
           </a:p>
@@ -3085,7 +3090,7 @@
           <a:p>
             <a:fld id="{766B0C42-5065-4BF6-B693-914B09332802}" type="datetimeFigureOut">
               <a:rPr lang="en-US" smtClean="0"/>
-              <a:t>6/6/2026</a:t>
+              <a:t>6/7/2026</a:t>
             </a:fld>
             <a:endParaRPr lang="en-US"/>
           </a:p>
@@ -3388,7 +3393,7 @@
           <a:p>
             <a:fld id="{766B0C42-5065-4BF6-B693-914B09332802}" type="datetimeFigureOut">
               <a:rPr lang="en-US" smtClean="0"/>
-              <a:t>6/6/2026</a:t>
+              <a:t>6/7/2026</a:t>
             </a:fld>
             <a:endParaRPr lang="en-US"/>
           </a:p>
@@ -3974,7 +3979,7 @@
         <p:spPr/>
         <p:txBody>
           <a:bodyPr>
-            <a:normAutofit fontScale="85000" lnSpcReduction="20000"/>
+            <a:normAutofit/>
           </a:bodyPr>
           <a:lstStyle/>
           <a:p>
@@ -3987,13 +3992,6 @@
           <a:p>
             <a:pPr algn="ctr"/>
             <a:endParaRPr lang="en-US" dirty="0"/>
-          </a:p>
-          <a:p>
-            <a:pPr algn="ctr"/>
-            <a:r>
-              <a:rPr lang="en-US" dirty="0"/>
-              <a:t>GitHub Link:</a:t>
-            </a:r>
           </a:p>
         </p:txBody>
       </p:sp>

</xml_diff>